<commit_message>
Finalize report and presentation with verified cloud and Colab evidence
</commit_message>
<xml_diff>
--- a/deliverables/DigitLab-presentation.pptx
+++ b/deliverables/DigitLab-presentation.pptx
@@ -2,21 +2,21 @@
 <file path=ppt/presentation.xml><?xml version="1.0" encoding="utf-8"?>
 <p:presentation xmlns:p="http://schemas.openxmlformats.org/presentationml/2006/main">
   <p:sldMasterIdLst>
-    <p:sldMasterId xmlns:r="http://schemas.openxmlformats.org/officeDocument/2006/relationships" id="2147483648" r:id="R40047bd6a1d14e27"/>
+    <p:sldMasterId xmlns:r="http://schemas.openxmlformats.org/officeDocument/2006/relationships" id="2147483648" r:id="Rdfe234cab542497c"/>
   </p:sldMasterIdLst>
   <p:notesMasterIdLst>
-    <p:notesMasterId xmlns:r="http://schemas.openxmlformats.org/officeDocument/2006/relationships" r:id="R85c84381323e4528"/>
+    <p:notesMasterId xmlns:r="http://schemas.openxmlformats.org/officeDocument/2006/relationships" r:id="R4e8958c60c0f4dba"/>
   </p:notesMasterIdLst>
   <p:sldIdLst>
-    <p:sldId xmlns:r="http://schemas.openxmlformats.org/officeDocument/2006/relationships" id="256" r:id="Rc2975acc0f5c4b0e"/>
-    <p:sldId xmlns:r="http://schemas.openxmlformats.org/officeDocument/2006/relationships" id="257" r:id="R4d23de41077c40c4"/>
-    <p:sldId xmlns:r="http://schemas.openxmlformats.org/officeDocument/2006/relationships" id="258" r:id="Ra432c59da8594152"/>
-    <p:sldId xmlns:r="http://schemas.openxmlformats.org/officeDocument/2006/relationships" id="259" r:id="R530f275693004b1a"/>
-    <p:sldId xmlns:r="http://schemas.openxmlformats.org/officeDocument/2006/relationships" id="260" r:id="Rb439c9b5e0ab4c3c"/>
-    <p:sldId xmlns:r="http://schemas.openxmlformats.org/officeDocument/2006/relationships" id="261" r:id="R977896d56a98428d"/>
-    <p:sldId xmlns:r="http://schemas.openxmlformats.org/officeDocument/2006/relationships" id="262" r:id="Raa9b2b530e9a491d"/>
-    <p:sldId xmlns:r="http://schemas.openxmlformats.org/officeDocument/2006/relationships" id="263" r:id="R7a957e9e1e644b93"/>
-    <p:sldId xmlns:r="http://schemas.openxmlformats.org/officeDocument/2006/relationships" id="264" r:id="Rfa847aaa19ce485b"/>
+    <p:sldId xmlns:r="http://schemas.openxmlformats.org/officeDocument/2006/relationships" id="256" r:id="Re858bd18ecf44c9a"/>
+    <p:sldId xmlns:r="http://schemas.openxmlformats.org/officeDocument/2006/relationships" id="257" r:id="R13b2d7f0b3574b48"/>
+    <p:sldId xmlns:r="http://schemas.openxmlformats.org/officeDocument/2006/relationships" id="258" r:id="R9659738aae704d4c"/>
+    <p:sldId xmlns:r="http://schemas.openxmlformats.org/officeDocument/2006/relationships" id="259" r:id="Ra8b7e4cf2a8a496f"/>
+    <p:sldId xmlns:r="http://schemas.openxmlformats.org/officeDocument/2006/relationships" id="260" r:id="R3fe720ca4beb4c85"/>
+    <p:sldId xmlns:r="http://schemas.openxmlformats.org/officeDocument/2006/relationships" id="261" r:id="R167befd55bd449cc"/>
+    <p:sldId xmlns:r="http://schemas.openxmlformats.org/officeDocument/2006/relationships" id="262" r:id="R71755a9968394d72"/>
+    <p:sldId xmlns:r="http://schemas.openxmlformats.org/officeDocument/2006/relationships" id="263" r:id="R02fee3ff0494436b"/>
+    <p:sldId xmlns:r="http://schemas.openxmlformats.org/officeDocument/2006/relationships" id="264" r:id="R009d5a30e0794f5e"/>
   </p:sldIdLst>
   <p:sldSz cx="12192000" cy="6858000"/>
   <p:notesSz cx="6858000" cy="9144000"/>
@@ -4053,17 +4053,17 @@
   </p:cSld>
   <p:clrMap bg1="lt1" tx1="dk1" bg2="lt2" tx2="dk2" accent1="accent1" accent2="accent2" accent3="accent3" accent4="accent4" accent5="accent5" accent6="accent6" hlink="hlink" folHlink="folHlink"/>
   <p:sldLayoutIdLst>
-    <p:sldLayoutId xmlns:r="http://schemas.openxmlformats.org/officeDocument/2006/relationships" id="2147483649" r:id="Rd501487561ae43ba"/>
-    <p:sldLayoutId xmlns:r="http://schemas.openxmlformats.org/officeDocument/2006/relationships" id="2147483650" r:id="R7f9c526b3eac4a59"/>
-    <p:sldLayoutId xmlns:r="http://schemas.openxmlformats.org/officeDocument/2006/relationships" id="2147483651" r:id="Rffb8b970c3da4954"/>
-    <p:sldLayoutId xmlns:r="http://schemas.openxmlformats.org/officeDocument/2006/relationships" id="2147483652" r:id="R8c050c14e45a4604"/>
-    <p:sldLayoutId xmlns:r="http://schemas.openxmlformats.org/officeDocument/2006/relationships" id="2147483653" r:id="R646b12b3da3648b7"/>
-    <p:sldLayoutId xmlns:r="http://schemas.openxmlformats.org/officeDocument/2006/relationships" id="2147483654" r:id="Re116bbf32f404da3"/>
-    <p:sldLayoutId xmlns:r="http://schemas.openxmlformats.org/officeDocument/2006/relationships" id="2147483655" r:id="Ra0436257ce5247df"/>
-    <p:sldLayoutId xmlns:r="http://schemas.openxmlformats.org/officeDocument/2006/relationships" id="2147483656" r:id="Ra41b67b607964fdc"/>
-    <p:sldLayoutId xmlns:r="http://schemas.openxmlformats.org/officeDocument/2006/relationships" id="2147483657" r:id="R6fc198a315ba4d99"/>
-    <p:sldLayoutId xmlns:r="http://schemas.openxmlformats.org/officeDocument/2006/relationships" id="2147483658" r:id="R1687cffc04a24895"/>
-    <p:sldLayoutId xmlns:r="http://schemas.openxmlformats.org/officeDocument/2006/relationships" id="2147483659" r:id="Rd27760fbbde540c1"/>
+    <p:sldLayoutId xmlns:r="http://schemas.openxmlformats.org/officeDocument/2006/relationships" id="2147483649" r:id="Rf79c90a5c11648c1"/>
+    <p:sldLayoutId xmlns:r="http://schemas.openxmlformats.org/officeDocument/2006/relationships" id="2147483650" r:id="R70ef1d84869b4d16"/>
+    <p:sldLayoutId xmlns:r="http://schemas.openxmlformats.org/officeDocument/2006/relationships" id="2147483651" r:id="R2e6a8525911d4ada"/>
+    <p:sldLayoutId xmlns:r="http://schemas.openxmlformats.org/officeDocument/2006/relationships" id="2147483652" r:id="R76d96531fa8b4345"/>
+    <p:sldLayoutId xmlns:r="http://schemas.openxmlformats.org/officeDocument/2006/relationships" id="2147483653" r:id="R302f761568794317"/>
+    <p:sldLayoutId xmlns:r="http://schemas.openxmlformats.org/officeDocument/2006/relationships" id="2147483654" r:id="R1215a14275c247d6"/>
+    <p:sldLayoutId xmlns:r="http://schemas.openxmlformats.org/officeDocument/2006/relationships" id="2147483655" r:id="R5e6501a72b794929"/>
+    <p:sldLayoutId xmlns:r="http://schemas.openxmlformats.org/officeDocument/2006/relationships" id="2147483656" r:id="R09bbb9e85fbd4cbf"/>
+    <p:sldLayoutId xmlns:r="http://schemas.openxmlformats.org/officeDocument/2006/relationships" id="2147483657" r:id="Re68e1846e99a46c0"/>
+    <p:sldLayoutId xmlns:r="http://schemas.openxmlformats.org/officeDocument/2006/relationships" id="2147483658" r:id="R3f2f31037b714470"/>
+    <p:sldLayoutId xmlns:r="http://schemas.openxmlformats.org/officeDocument/2006/relationships" id="2147483659" r:id="R90d6e2e5a4744ac6"/>
   </p:sldLayoutIdLst>
   <p:txStyles>
     <p:titleStyle>
@@ -4656,7 +4656,7 @@
           <p:cNvPr id="2" name="Рисунок 1">
             <a:extLst xmlns:a="http://schemas.openxmlformats.org/drawingml/2006/main">
               <a:ext uri="{FF2B5EF4-FFF2-40B4-BE49-F238E27FC236}">
-                <a16:creationId xmlns:a16="http://schemas.microsoft.com/office/drawing/2014/main" id="{885E76F8-18E0-43B0-87C8-11EE5F70315F}"/>
+                <a16:creationId xmlns:a16="http://schemas.microsoft.com/office/drawing/2014/main" id="{EF175EE6-C6A4-4CB1-9D8A-54060C96BA3C}"/>
               </a:ext>
             </a:extLst>
           </p:cNvPr>
@@ -4666,7 +4666,7 @@
           <p:nvPr/>
         </p:nvPicPr>
         <p:blipFill>
-          <a:blip xmlns:r="http://schemas.openxmlformats.org/officeDocument/2006/relationships" xmlns:a="http://schemas.openxmlformats.org/drawingml/2006/main" r:embed="Rd30615ea53eb4344"/>
+          <a:blip xmlns:r="http://schemas.openxmlformats.org/officeDocument/2006/relationships" xmlns:a="http://schemas.openxmlformats.org/drawingml/2006/main" r:embed="R73694c005dae4356"/>
           <a:stretch xmlns:a="http://schemas.openxmlformats.org/drawingml/2006/main">
             <a:fillRect l="0" t="0" r="0" b="0"/>
           </a:stretch>
@@ -4686,7 +4686,7 @@
           <p:cNvPr id="6" name="Заголовок 1">
             <a:extLst xmlns:a="http://schemas.openxmlformats.org/drawingml/2006/main">
               <a:ext uri="{FF2B5EF4-FFF2-40B4-BE49-F238E27FC236}">
-                <a16:creationId xmlns:a16="http://schemas.microsoft.com/office/drawing/2014/main" id="{86869753-9F3B-4C53-8E56-7E7076CF1F46}"/>
+                <a16:creationId xmlns:a16="http://schemas.microsoft.com/office/drawing/2014/main" id="{695AC07B-23A7-486B-9E0D-090BF5093CB6}"/>
               </a:ext>
             </a:extLst>
           </p:cNvPr>
@@ -7466,7 +7466,7 @@
           <p:cNvPr id="8" name="">
             <a:extLst xmlns:a="http://schemas.openxmlformats.org/drawingml/2006/main">
               <a:ext uri="{FF2B5EF4-FFF2-40B4-BE49-F238E27FC236}">
-                <a16:creationId xmlns:a16="http://schemas.microsoft.com/office/drawing/2014/main" id="{A1CA48CA-967F-464C-976F-EAB07BD66B0F}"/>
+                <a16:creationId xmlns:a16="http://schemas.microsoft.com/office/drawing/2014/main" id="{18A2A89E-00F1-441A-A9AD-CF1ADCD301E8}"/>
               </a:ext>
             </a:extLst>
           </p:cNvPr>
@@ -7476,7 +7476,7 @@
           <p:nvPr/>
         </p:nvPicPr>
         <p:blipFill>
-          <a:blip xmlns:r="http://schemas.openxmlformats.org/officeDocument/2006/relationships" xmlns:a="http://schemas.openxmlformats.org/drawingml/2006/main" r:embed="R952aa2bb913f4775"/>
+          <a:blip xmlns:r="http://schemas.openxmlformats.org/officeDocument/2006/relationships" xmlns:a="http://schemas.openxmlformats.org/drawingml/2006/main" r:embed="R347342a80e3f485a"/>
           <a:stretch xmlns:a="http://schemas.openxmlformats.org/drawingml/2006/main"/>
         </p:blipFill>
         <p:spPr>
@@ -7931,7 +7931,7 @@
                 <a:ea typeface="Arial"/>
                 <a:cs typeface="Arial"/>
               </a:rPr>
-              <a:t>GitHub: https://github.com/PoM1nkey</a:t>
+              <a:t>Репозиторий: https://github.com/PoM1nkey/digitlab</a:t>
             </a:r>
           </a:p>
           <a:p xmlns:a="http://schemas.openxmlformats.org/drawingml/2006/main">
@@ -8083,7 +8083,7 @@
                 <a:ea typeface="Arial"/>
                 <a:cs typeface="Arial"/>
               </a:rPr>
-              <a:t>Репозиторий публикуется после локальной проверки</a:t>
+              <a:t>Код опубликован, первый запуск CI успешен</a:t>
             </a:r>
           </a:p>
         </p:txBody>
@@ -8496,7 +8496,7 @@
         <p:spPr>
           <a:xfrm xmlns:a="http://schemas.openxmlformats.org/drawingml/2006/main">
             <a:off x="571500" y="1333500"/>
-            <a:ext cx="10953750" cy="2853690"/>
+            <a:ext cx="10953750" cy="3162300"/>
           </a:xfrm>
           <a:prstGeom xmlns:a="http://schemas.openxmlformats.org/drawingml/2006/main" prst="rect">
             <a:avLst/>
@@ -8629,7 +8629,7 @@
                 <a:ea typeface="Arial"/>
                 <a:cs typeface="Arial"/>
               </a:rPr>
-              <a:t>pytest проверяет реальный инференс и HTTP API</a:t>
+              <a:t>9 автотестов успешно пройдены локально</a:t>
             </a:r>
           </a:p>
           <a:p xmlns:a="http://schemas.openxmlformats.org/drawingml/2006/main">
@@ -8653,7 +8653,31 @@
                 <a:ea typeface="Arial"/>
                 <a:cs typeface="Arial"/>
               </a:rPr>
-              <a:t>Проверяются ошибки входа, лимит файла и вероятности</a:t>
+              <a:t>Первый запуск GitHub Actions успешен</a:t>
+            </a:r>
+          </a:p>
+          <a:p xmlns:a="http://schemas.openxmlformats.org/drawingml/2006/main">
+            <a:pPr marL="0" indent="0" algn="l">
+              <a:buNone/>
+              <a:defRPr sz="2025" b="0">
+                <a:solidFill>
+                  <a:srgbClr val="000000"/>
+                </a:solidFill>
+                <a:latin typeface="Arial"/>
+                <a:ea typeface="Arial"/>
+                <a:cs typeface="Arial"/>
+              </a:defRPr>
+            </a:pPr>
+            <a:r>
+              <a:rPr sz="2025" b="0">
+                <a:solidFill>
+                  <a:srgbClr val="000000"/>
+                </a:solidFill>
+                <a:latin typeface="Arial"/>
+                <a:ea typeface="Arial"/>
+                <a:cs typeface="Arial"/>
+              </a:rPr>
+              <a:t>https://github.com/PoM1nkey/digitlab/actions</a:t>
             </a:r>
           </a:p>
           <a:p xmlns:a="http://schemas.openxmlformats.org/drawingml/2006/main">
@@ -8717,31 +8741,7 @@
                 <a:ea typeface="Arial"/>
                 <a:cs typeface="Arial"/>
               </a:rPr>
-              <a:t>CD вызывает deploy hook после успешных тестов</a:t>
-            </a:r>
-          </a:p>
-          <a:p xmlns:a="http://schemas.openxmlformats.org/drawingml/2006/main">
-            <a:pPr marL="0" indent="0" algn="l">
-              <a:buNone/>
-              <a:defRPr sz="2025" b="0">
-                <a:solidFill>
-                  <a:srgbClr val="000000"/>
-                </a:solidFill>
-                <a:latin typeface="Arial"/>
-                <a:ea typeface="Arial"/>
-                <a:cs typeface="Arial"/>
-              </a:defRPr>
-            </a:pPr>
-            <a:r>
-              <a:rPr sz="2025" b="0">
-                <a:solidFill>
-                  <a:srgbClr val="000000"/>
-                </a:solidFill>
-                <a:latin typeface="Arial"/>
-                <a:ea typeface="Arial"/>
-                <a:cs typeface="Arial"/>
-              </a:rPr>
-              <a:t>Для CD требуется секрет DEPLOY_HOOK</a:t>
+              <a:t>CD подготовлен, но DEPLOY_HOOK не настроен</a:t>
             </a:r>
           </a:p>
           <a:p xmlns:a="http://schemas.openxmlformats.org/drawingml/2006/main">
@@ -8781,7 +8781,7 @@
                 <a:ea typeface="Arial"/>
                 <a:cs typeface="Arial"/>
               </a:rPr>
-              <a:t>Docker запускает Streamlit и FastAPI</a:t>
+              <a:t>Облако: Streamlit Community Cloud</a:t>
             </a:r>
           </a:p>
           <a:p xmlns:a="http://schemas.openxmlformats.org/drawingml/2006/main">
@@ -8805,7 +8805,31 @@
                 <a:ea typeface="Arial"/>
                 <a:cs typeface="Arial"/>
               </a:rPr>
-              <a:t>Облачная публикация требует отдельного запуска</a:t>
+              <a:t>https://digits-pom1nkey.streamlit.app/</a:t>
+            </a:r>
+          </a:p>
+          <a:p xmlns:a="http://schemas.openxmlformats.org/drawingml/2006/main">
+            <a:pPr marL="0" indent="0" algn="l">
+              <a:buNone/>
+              <a:defRPr sz="2025" b="0">
+                <a:solidFill>
+                  <a:srgbClr val="000000"/>
+                </a:solidFill>
+                <a:latin typeface="Arial"/>
+                <a:ea typeface="Arial"/>
+                <a:cs typeface="Arial"/>
+              </a:defRPr>
+            </a:pPr>
+            <a:r>
+              <a:rPr sz="2025" b="0">
+                <a:solidFill>
+                  <a:srgbClr val="000000"/>
+                </a:solidFill>
+                <a:latin typeface="Arial"/>
+                <a:ea typeface="Arial"/>
+                <a:cs typeface="Arial"/>
+              </a:rPr>
+              <a:t>Модель также успешно выполнена в Google Colab</a:t>
             </a:r>
           </a:p>
         </p:txBody>

</xml_diff>